<commit_message>
feat: governed evidence engine - cloud integrations, live feed, evidence Q&A, replay, verify-chain, tests; remove legacy modules
</commit_message>
<xml_diff>
--- a/submission/ScopeShift-HackSprint-Phase2-8slide.pptx
+++ b/submission/ScopeShift-HackSprint-Phase2-8slide.pptx
@@ -3134,7 +3134,7 @@
                 </a:solidFill>
                 <a:latin typeface="Calibri"/>
               </a:rPr>
-              <a:t>ScopeShift  |  PS/P42  |  1/8</a:t>
+              <a:t>ScopeShift  |  Enterprise Edition  |  1/8</a:t>
             </a:r>
           </a:p>
         </p:txBody>
@@ -3169,7 +3169,7 @@
                 </a:solidFill>
                 <a:latin typeface="Calibri"/>
               </a:rPr>
-              <a:t>PS/P42  |  EVIDENCE-GOVERNED BRD GENERATOR</a:t>
+              <a:t>ENTERPRISE  |  EVIDENCE-GOVERNED BRD GENERATOR</a:t>
             </a:r>
           </a:p>
         </p:txBody>
@@ -3453,7 +3453,7 @@
                 </a:solidFill>
                 <a:latin typeface="Calibri"/>
               </a:rPr>
-              <a:t>ScopeShift  |  PS/P42  |  2/8</a:t>
+              <a:t>ScopeShift  |  Enterprise Edition  |  2/8</a:t>
             </a:r>
           </a:p>
         </p:txBody>
@@ -4078,7 +4078,7 @@
                 </a:solidFill>
                 <a:latin typeface="Calibri"/>
               </a:rPr>
-              <a:t>ScopeShift  |  PS/P42  |  3/8</a:t>
+              <a:t>ScopeShift  |  Enterprise Edition  |  3/8</a:t>
             </a:r>
           </a:p>
         </p:txBody>
@@ -5192,7 +5192,7 @@
                 </a:solidFill>
                 <a:latin typeface="Calibri"/>
               </a:rPr>
-              <a:t>ScopeShift  |  PS/P42  |  4/8</a:t>
+              <a:t>ScopeShift  |  Enterprise Edition  |  4/8</a:t>
             </a:r>
           </a:p>
         </p:txBody>
@@ -6298,7 +6298,7 @@
                 </a:solidFill>
                 <a:latin typeface="Calibri"/>
               </a:rPr>
-              <a:t>ScopeShift  |  PS/P42  |  5/8</a:t>
+              <a:t>ScopeShift  |  Enterprise Edition  |  5/8</a:t>
             </a:r>
           </a:p>
         </p:txBody>
@@ -6834,13 +6834,13 @@
           <a:p>
             <a:pPr algn="l"/>
             <a:r>
-              <a:rPr sz="1400" b="1" i="0">
+              <a:rPr sz="1300" b="1" i="0">
                 <a:solidFill>
                   <a:srgbClr val="60A5FA"/>
                 </a:solidFill>
                 <a:latin typeface="Calibri"/>
               </a:rPr>
-              <a:t>Live Interactive Cockpit: 3D Spatial Topology Matrix (Three.js) • Time-Travel Scrubber • Deep Citation Inspector</a:t>
+              <a:t>Live Interactive Cockpit: 3D Spatial Topology Matrix (Three.js) • Live SSE Evidence Feed • Time-Travel Scrubber • Ask-the-Evidence Q&amp;A • Contradiction Heatmap • Automated Simulation Walkthrough</a:t>
             </a:r>
           </a:p>
         </p:txBody>
@@ -6971,7 +6971,7 @@
                 </a:solidFill>
                 <a:latin typeface="Calibri"/>
               </a:rPr>
-              <a:t>ScopeShift  |  PS/P42  |  6/8</a:t>
+              <a:t>ScopeShift  |  Enterprise Edition  |  6/8</a:t>
             </a:r>
           </a:p>
         </p:txBody>
@@ -7098,7 +7098,7 @@
                 </a:solidFill>
                 <a:latin typeface="Calibri"/>
               </a:rPr>
-              <a:t>Gemini structured extraction</a:t>
+              <a:t>Gemini structured extraction (Vertex AI route)</a:t>
             </a:r>
           </a:p>
         </p:txBody>
@@ -7133,7 +7133,7 @@
                 </a:solidFill>
                 <a:latin typeface="Calibri"/>
               </a:rPr>
-              <a:t>Claims constrained to an enum of claim IDs, with quote and proposed scope change.</a:t>
+              <a:t>Claims constrained to an enum of claim IDs, with quote and proposed scope change. Vertex AI endpoint when GOOGLE_CLOUD_PROJECT is set; deterministic fallback offline.</a:t>
             </a:r>
           </a:p>
         </p:txBody>
@@ -7295,7 +7295,7 @@
                 </a:solidFill>
                 <a:latin typeface="Calibri"/>
               </a:rPr>
-              <a:t>Quotes must exist in the source text. Hallucinated claims are rejected.</a:t>
+              <a:t>Quotes must exist in the source text. Screenshots can never govern. Hallucinated claims are rejected; chaos attacks are executed, not scripted.</a:t>
             </a:r>
           </a:p>
         </p:txBody>
@@ -7422,7 +7422,7 @@
                 </a:solidFill>
                 <a:latin typeface="Calibri"/>
               </a:rPr>
-              <a:t>BigQuery append-only event log</a:t>
+              <a:t>BigQuery append-only event log (env-gated)</a:t>
             </a:r>
           </a:p>
         </p:txBody>
@@ -7457,7 +7457,7 @@
                 </a:solidFill>
                 <a:latin typeface="Calibri"/>
               </a:rPr>
-              <a:t>ADDED and REMOVED events, ordered by sequence. Insert-only by application design.</a:t>
+              <a:t>ADDED and REMOVED events streamed to BigQuery when credentials exist; SQLite is the persisted local mirror. Insert-only by application design.</a:t>
             </a:r>
           </a:p>
         </p:txBody>
@@ -7584,7 +7584,7 @@
                 </a:solidFill>
                 <a:latin typeface="Calibri"/>
               </a:rPr>
-              <a:t>Generic deterministic resolver</a:t>
+              <a:t>Live SSE feed + deterministic resolver</a:t>
             </a:r>
           </a:p>
         </p:txBody>
@@ -7619,7 +7619,7 @@
                 </a:solidFill>
                 <a:latin typeface="Calibri"/>
               </a:rPr>
-              <a:t>resolve(claim_id, active_evidence). Keyed by claim, not by payment methods.</a:t>
+              <a:t>Evidence streams in real time; resolve(claim_id, active_evidence) recomputes live. Citation integrity is fail-closed: dangling citations refuse to serve.</a:t>
             </a:r>
           </a:p>
         </p:txBody>
@@ -7702,7 +7702,7 @@
                 </a:solidFill>
                 <a:latin typeface="Calibri"/>
               </a:rPr>
-              <a:t>BigQuery is the persisted append-only log. The demo reads through an in-memory mirror of it.</a:t>
+              <a:t>Cloud integrations are env-gated: the demo runs fully offline on the local mirror; with GCP credentials it streams to BigQuery / Cloud Storage / Vertex AI.</a:t>
             </a:r>
           </a:p>
         </p:txBody>
@@ -7833,7 +7833,7 @@
                 </a:solidFill>
                 <a:latin typeface="Calibri"/>
               </a:rPr>
-              <a:t>ScopeShift  |  PS/P42  |  7/8</a:t>
+              <a:t>ScopeShift  |  Enterprise Edition  |  7/8</a:t>
             </a:r>
           </a:p>
         </p:txBody>
@@ -8196,7 +8196,7 @@
                 </a:solidFill>
                 <a:latin typeface="Calibri"/>
               </a:rPr>
-              <a:t>BUILD PLAN AND IMPACT</a:t>
+              <a:t>BUILD STATUS</a:t>
             </a:r>
           </a:p>
         </p:txBody>
@@ -8231,7 +8231,7 @@
                 </a:solidFill>
                 <a:latin typeface="Calibri"/>
               </a:rPr>
-              <a:t>A 24-hour build, scoped to one unforgettable scenario.</a:t>
+              <a:t>Built, tested, and demo-ready.</a:t>
             </a:r>
           </a:p>
         </p:txBody>
@@ -8266,7 +8266,7 @@
                 </a:solidFill>
                 <a:latin typeface="Calibri"/>
               </a:rPr>
-              <a:t>ScopeShift  |  PS/P42  |  8/8</a:t>
+              <a:t>ScopeShift  |  Enterprise Edition  |  8/8</a:t>
             </a:r>
           </a:p>
         </p:txBody>
@@ -8349,7 +8349,7 @@
                 </a:solidFill>
                 <a:latin typeface="Calibri"/>
               </a:rPr>
-              <a:t>1</a:t>
+              <a:t>✓</a:t>
             </a:r>
           </a:p>
         </p:txBody>
@@ -8384,7 +8384,7 @@
                 </a:solidFill>
                 <a:latin typeface="Calibri"/>
               </a:rPr>
-              <a:t>Ingest PDF, screenshot, client note</a:t>
+              <a:t>Multi-claim extraction + validation</a:t>
             </a:r>
           </a:p>
         </p:txBody>
@@ -8467,7 +8467,7 @@
                 </a:solidFill>
                 <a:latin typeface="Calibri"/>
               </a:rPr>
-              <a:t>2</a:t>
+              <a:t>✓</a:t>
             </a:r>
           </a:p>
         </p:txBody>
@@ -8502,7 +8502,7 @@
                 </a:solidFill>
                 <a:latin typeface="Calibri"/>
               </a:rPr>
-              <a:t>Extract structured evidence</a:t>
+              <a:t>BigQuery/GCS/Vertex env-gated integrations</a:t>
             </a:r>
           </a:p>
         </p:txBody>
@@ -8585,7 +8585,7 @@
                 </a:solidFill>
                 <a:latin typeface="Calibri"/>
               </a:rPr>
-              <a:t>3</a:t>
+              <a:t>✓</a:t>
             </a:r>
           </a:p>
         </p:txBody>
@@ -8620,7 +8620,7 @@
                 </a:solidFill>
                 <a:latin typeface="Calibri"/>
               </a:rPr>
-              <a:t>Validate citations</a:t>
+              <a:t>Live SSE evidence feed</a:t>
             </a:r>
           </a:p>
         </p:txBody>
@@ -8703,7 +8703,7 @@
                 </a:solidFill>
                 <a:latin typeface="Calibri"/>
               </a:rPr>
-              <a:t>4</a:t>
+              <a:t>✓</a:t>
             </a:r>
           </a:p>
         </p:txBody>
@@ -8738,7 +8738,7 @@
                 </a:solidFill>
                 <a:latin typeface="Calibri"/>
               </a:rPr>
-              <a:t>Run resolver</a:t>
+              <a:t>Deterministic resolver + fail-closed citations</a:t>
             </a:r>
           </a:p>
         </p:txBody>
@@ -8821,7 +8821,7 @@
                 </a:solidFill>
                 <a:latin typeface="Calibri"/>
               </a:rPr>
-              <a:t>5</a:t>
+              <a:t>✓</a:t>
             </a:r>
           </a:p>
         </p:txBody>
@@ -8856,7 +8856,7 @@
                 </a:solidFill>
                 <a:latin typeface="Calibri"/>
               </a:rPr>
-              <a:t>Demonstrate three state transitions</a:t>
+              <a:t>Ask-the-evidence + heatmap + 3D twin</a:t>
             </a:r>
           </a:p>
         </p:txBody>
@@ -8939,7 +8939,7 @@
                 </a:solidFill>
                 <a:latin typeface="Calibri"/>
               </a:rPr>
-              <a:t>6</a:t>
+              <a:t>✓</a:t>
             </a:r>
           </a:p>
         </p:txBody>
@@ -8974,7 +8974,7 @@
                 </a:solidFill>
                 <a:latin typeface="Calibri"/>
               </a:rPr>
-              <a:t>Package replayable demo + fallback</a:t>
+              <a:t>90 automated tests green</a:t>
             </a:r>
           </a:p>
         </p:txBody>
@@ -9153,7 +9153,7 @@
                 </a:solidFill>
                 <a:latin typeface="Calibri"/>
               </a:rPr>
-              <a:t>Empirical validation: Plain Gemini vs Hinted vs ScopeShift</a:t>
+              <a:t>Baseline: SIMULATED model stand-in — live Gemini run pending</a:t>
             </a:r>
           </a:p>
         </p:txBody>
@@ -9188,21 +9188,104 @@
                 </a:solidFill>
                 <a:latin typeface="Calibri"/>
               </a:rPr>
-              <a:t>ScopeShift  |  PS/P42  |  Appendix</a:t>
-            </a:r>
-          </a:p>
-        </p:txBody>
-      </p:sp>
-      <p:sp>
-        <p:nvSpPr>
-          <p:cNvPr id="5" name="TextBox 4"/>
+              <a:t>ScopeShift  |  Enterprise Edition  |  Appendix</a:t>
+            </a:r>
+          </a:p>
+        </p:txBody>
+      </p:sp>
+      <p:sp>
+        <p:nvSpPr>
+          <p:cNvPr id="5" name="Rounded Rectangle 4"/>
+          <p:cNvSpPr/>
+          <p:nvPr/>
+        </p:nvSpPr>
+        <p:spPr>
+          <a:xfrm>
+            <a:off x="640080" y="1417320"/>
+            <a:ext cx="3108960" cy="502920"/>
+          </a:xfrm>
+          <a:prstGeom prst="roundRect">
+            <a:avLst>
+              <a:gd name="adj" fmla="val 6000"/>
+            </a:avLst>
+          </a:prstGeom>
+          <a:solidFill>
+            <a:srgbClr val="151C33"/>
+          </a:solidFill>
+          <a:ln w="25400">
+            <a:solidFill>
+              <a:srgbClr val="EF4444"/>
+            </a:solidFill>
+          </a:ln>
+          <a:effectLst/>
+        </p:spPr>
+        <p:style>
+          <a:lnRef idx="1">
+            <a:schemeClr val="accent1"/>
+          </a:lnRef>
+          <a:fillRef idx="3">
+            <a:schemeClr val="accent1"/>
+          </a:fillRef>
+          <a:effectRef idx="2">
+            <a:schemeClr val="accent1"/>
+          </a:effectRef>
+          <a:fontRef idx="minor">
+            <a:schemeClr val="lt1"/>
+          </a:fontRef>
+        </p:style>
+        <p:txBody>
+          <a:bodyPr rtlCol="0" anchor="ctr"/>
+          <a:lstStyle/>
+          <a:p>
+            <a:pPr algn="ctr"/>
+          </a:p>
+        </p:txBody>
+      </p:sp>
+      <p:sp>
+        <p:nvSpPr>
+          <p:cNvPr id="6" name="TextBox 5"/>
           <p:cNvSpPr txBox="1"/>
           <p:nvPr/>
         </p:nvSpPr>
         <p:spPr>
           <a:xfrm>
-            <a:off x="640080" y="1463040"/>
-            <a:ext cx="10881360" cy="365760"/>
+            <a:off x="731520" y="1417320"/>
+            <a:ext cx="2926080" cy="502920"/>
+          </a:xfrm>
+          <a:prstGeom prst="rect">
+            <a:avLst/>
+          </a:prstGeom>
+          <a:noFill/>
+        </p:spPr>
+        <p:txBody>
+          <a:bodyPr wrap="square" anchor="ctr" lIns="45720" rIns="45720">
+            <a:spAutoFit/>
+          </a:bodyPr>
+          <a:lstStyle/>
+          <a:p>
+            <a:pPr algn="ctr"/>
+            <a:r>
+              <a:rPr sz="1500" b="1" i="0">
+                <a:solidFill>
+                  <a:srgbClr val="EF4444"/>
+                </a:solidFill>
+                <a:latin typeface="Calibri"/>
+              </a:rPr>
+              <a:t>⚠ SIMULATED — NOT MEASURED ON GEMINI</a:t>
+            </a:r>
+          </a:p>
+        </p:txBody>
+      </p:sp>
+      <p:sp>
+        <p:nvSpPr>
+          <p:cNvPr id="7" name="TextBox 6"/>
+          <p:cNvSpPr txBox="1"/>
+          <p:nvPr/>
+        </p:nvSpPr>
+        <p:spPr>
+          <a:xfrm>
+            <a:off x="4023360" y="1417320"/>
+            <a:ext cx="7498079" cy="548640"/>
           </a:xfrm>
           <a:prstGeom prst="rect">
             <a:avLst/>
@@ -9217,28 +9300,28 @@
           <a:p>
             <a:pPr algn="l"/>
             <a:r>
-              <a:rPr sz="1500" b="0" i="0">
+              <a:rPr sz="1400" b="0" i="0">
                 <a:solidFill>
                   <a:srgbClr val="94A3B8"/>
                 </a:solidFill>
                 <a:latin typeface="Calibri"/>
               </a:rPr>
-              <a:t>Controlled experiment: 10 independent runs per condition on checkout fixtures (API default temp).</a:t>
+              <a:t>mock-gemini-preview stand-in • 5 runs per condition • API-default temperature • source: baseline_out/*/summary.md (unedited). Live 10-run Gemini baseline runs on the stage laptop with GEMINI_API_KEY.</a:t>
             </a:r>
           </a:p>
         </p:txBody>
       </p:sp>
       <p:graphicFrame>
         <p:nvGraphicFramePr>
-          <p:cNvPr id="6" name="Table 5"/>
+          <p:cNvPr id="8" name="Table 7"/>
           <p:cNvGraphicFramePr>
             <a:graphicFrameLocks noGrp="1"/>
           </p:cNvGraphicFramePr>
           <p:nvPr/>
         </p:nvGraphicFramePr>
         <p:xfrm>
-          <a:off x="640080" y="1920240"/>
-          <a:ext cx="10881360" cy="2926080"/>
+          <a:off x="640080" y="2103120"/>
+          <a:ext cx="10881360" cy="2743200"/>
         </p:xfrm>
         <a:graphic>
           <a:graphicData uri="http://schemas.openxmlformats.org/drawingml/2006/table">
@@ -9252,7 +9335,7 @@
                 <a:gridCol w="3474720"/>
                 <a:gridCol w="2103120"/>
               </a:tblGrid>
-              <a:tr h="731520">
+              <a:tr h="685800">
                 <a:tc>
                   <a:txBody>
                     <a:bodyPr/>
@@ -9287,7 +9370,7 @@
                           </a:solidFill>
                           <a:latin typeface="Calibri"/>
                         </a:rPr>
-                        <a:t>Test A (Note Present)</a:t>
+                        <a:t>Test A (note present)</a:t>
                       </a:r>
                     </a:p>
                   </a:txBody>
@@ -9309,7 +9392,7 @@
                           </a:solidFill>
                           <a:latin typeface="Calibri"/>
                         </a:rPr>
-                        <a:t>Test B (Note Removed / Screenshot Only)</a:t>
+                        <a:t>Test B (screenshot only)</a:t>
                       </a:r>
                     </a:p>
                   </a:txBody>
@@ -9331,7 +9414,7 @@
                           </a:solidFill>
                           <a:latin typeface="Calibri"/>
                         </a:rPr>
-                        <a:t>Citations Valid</a:t>
+                        <a:t>Citations</a:t>
                       </a:r>
                     </a:p>
                   </a:txBody>
@@ -9342,7 +9425,7 @@
                   </a:tcPr>
                 </a:tc>
               </a:tr>
-              <a:tr h="731520">
+              <a:tr h="685800">
                 <a:tc>
                   <a:txBody>
                     <a:bodyPr/>
@@ -9355,7 +9438,7 @@
                           </a:solidFill>
                           <a:latin typeface="Calibri"/>
                         </a:rPr>
-                        <a:t>Plain Gemini (No Hints)</a:t>
+                        <a:t>Plain (simulated)</a:t>
                       </a:r>
                     </a:p>
                   </a:txBody>
@@ -9377,7 +9460,7 @@
                           </a:solidFill>
                           <a:latin typeface="Calibri"/>
                         </a:rPr>
-                        <a:t>10/10 Card settled</a:t>
+                        <a:t>5/5 Card settled</a:t>
                       </a:r>
                     </a:p>
                   </a:txBody>
@@ -9399,7 +9482,7 @@
                           </a:solidFill>
                           <a:latin typeface="Calibri"/>
                         </a:rPr>
-                        <a:t>0/10 Correct (10/10 settled Card from UI button!)</a:t>
+                        <a:t>0/5 correct — 5/5 settled Card from the UI button</a:t>
                       </a:r>
                     </a:p>
                   </a:txBody>
@@ -9421,7 +9504,7 @@
                           </a:solidFill>
                           <a:latin typeface="Calibri"/>
                         </a:rPr>
-                        <a:t>0% (screenshot unverifiable)</a:t>
+                        <a:t>0 valid / 5 unverifiable</a:t>
                       </a:r>
                     </a:p>
                   </a:txBody>
@@ -9432,7 +9515,7 @@
                   </a:tcPr>
                 </a:tc>
               </a:tr>
-              <a:tr h="731520">
+              <a:tr h="685800">
                 <a:tc>
                   <a:txBody>
                     <a:bodyPr/>
@@ -9445,7 +9528,7 @@
                           </a:solidFill>
                           <a:latin typeface="Calibri"/>
                         </a:rPr>
-                        <a:t>Hinted Prompt</a:t>
+                        <a:t>Hinted (simulated)</a:t>
                       </a:r>
                     </a:p>
                   </a:txBody>
@@ -9467,7 +9550,7 @@
                           </a:solidFill>
                           <a:latin typeface="Calibri"/>
                         </a:rPr>
-                        <a:t>10/10 Card settled</a:t>
+                        <a:t>5/5 Card settled</a:t>
                       </a:r>
                     </a:p>
                   </a:txBody>
@@ -9489,7 +9572,7 @@
                           </a:solidFill>
                           <a:latin typeface="Calibri"/>
                         </a:rPr>
-                        <a:t>Flaky / Drift across runs</a:t>
+                        <a:t>5/5 conflict flagged</a:t>
                       </a:r>
                     </a:p>
                   </a:txBody>
@@ -9511,7 +9594,7 @@
                           </a:solidFill>
                           <a:latin typeface="Calibri"/>
                         </a:rPr>
-                        <a:t>Prompt-dependent</a:t>
+                        <a:t>5 valid / 0 unverifiable</a:t>
                       </a:r>
                     </a:p>
                   </a:txBody>
@@ -9522,7 +9605,7 @@
                   </a:tcPr>
                 </a:tc>
               </a:tr>
-              <a:tr h="731520">
+              <a:tr h="685800">
                 <a:tc>
                   <a:txBody>
                     <a:bodyPr/>
@@ -9535,7 +9618,7 @@
                           </a:solidFill>
                           <a:latin typeface="Calibri"/>
                         </a:rPr>
-                        <a:t>ScopeShift (Ours)</a:t>
+                        <a:t>ScopeShift (deterministic)</a:t>
                       </a:r>
                     </a:p>
                   </a:txBody>
@@ -9557,7 +9640,7 @@
                           </a:solidFill>
                           <a:latin typeface="Calibri"/>
                         </a:rPr>
-                        <a:t>100% GOVERNED</a:t>
+                        <a:t>GOVERNED on every replay</a:t>
                       </a:r>
                     </a:p>
                   </a:txBody>
@@ -9579,7 +9662,7 @@
                           </a:solidFill>
                           <a:latin typeface="Calibri"/>
                         </a:rPr>
-                        <a:t>100% DISPUTED (Requirement withheld)</a:t>
+                        <a:t>DISPUTED on every replay — withheld</a:t>
                       </a:r>
                     </a:p>
                   </a:txBody>
@@ -9601,7 +9684,7 @@
                           </a:solidFill>
                           <a:latin typeface="Calibri"/>
                         </a:rPr>
-                        <a:t>100% Code-verified</a:t>
+                        <a:t>Code-verified • fail-closed</a:t>
                       </a:r>
                     </a:p>
                   </a:txBody>
@@ -9618,7 +9701,7 @@
       </p:graphicFrame>
       <p:sp>
         <p:nvSpPr>
-          <p:cNvPr id="7" name="Rounded Rectangle 6"/>
+          <p:cNvPr id="9" name="Rounded Rectangle 8"/>
           <p:cNvSpPr/>
           <p:nvPr/>
         </p:nvSpPr>
@@ -9666,7 +9749,7 @@
       </p:sp>
       <p:sp>
         <p:nvSpPr>
-          <p:cNvPr id="8" name="TextBox 7"/>
+          <p:cNvPr id="10" name="TextBox 9"/>
           <p:cNvSpPr txBox="1"/>
           <p:nvPr/>
         </p:nvSpPr>
@@ -9694,8 +9777,8 @@
                 </a:solidFill>
                 <a:latin typeface="Calibri"/>
               </a:rPr>
-              <a:t>Takeaway: In Test B, unassisted LLMs treat the visible button as authority 100% of the time.
-ScopeShift separates extraction from authority, eliminating false positive requirements.</a:t>
+              <a:t>Takeaway: even simulated, the unhinted model treats the visible button as authority 5/5 in Test B.
+ScopeShift withholds the requirement deterministically — proven by 90 automated tests, not by model luck.</a:t>
             </a:r>
           </a:p>
         </p:txBody>

</xml_diff>